<commit_message>
Actualizaciones del proyecto, tras la presentación
</commit_message>
<xml_diff>
--- a/dice_fm_analisis_reseñas.pptx
+++ b/dice_fm_analisis_reseñas.pptx
@@ -1117,78 +1117,6 @@
       </p:sp>
       <p:sp>
         <p:nvSpPr>
-          <p:cNvPr id="3" name="Shape 1"/>
-          <p:cNvSpPr/>
-          <p:nvPr/>
-        </p:nvSpPr>
-        <p:spPr>
-          <a:xfrm>
-            <a:off x="7498080" y="-731520"/>
-            <a:ext cx="2560320" cy="2560320"/>
-          </a:xfrm>
-          <a:prstGeom prst="ellipse">
-            <a:avLst/>
-          </a:prstGeom>
-          <a:solidFill>
-            <a:srgbClr val="0077B6">
-              <a:alpha val="25000"/>
-            </a:srgbClr>
-          </a:solidFill>
-          <a:ln w="12700">
-            <a:solidFill>
-              <a:srgbClr val="FFFFFF">
-                <a:alpha val="0"/>
-              </a:srgbClr>
-            </a:solidFill>
-            <a:prstDash val="solid"/>
-          </a:ln>
-        </p:spPr>
-        <p:txBody>
-          <a:bodyPr/>
-          <a:lstStyle/>
-          <a:p>
-            <a:endParaRPr lang="es-ES"/>
-          </a:p>
-        </p:txBody>
-      </p:sp>
-      <p:sp>
-        <p:nvSpPr>
-          <p:cNvPr id="4" name="Shape 2"/>
-          <p:cNvSpPr/>
-          <p:nvPr/>
-        </p:nvSpPr>
-        <p:spPr>
-          <a:xfrm>
-            <a:off x="8046720" y="3291840"/>
-            <a:ext cx="1645920" cy="1645920"/>
-          </a:xfrm>
-          <a:prstGeom prst="ellipse">
-            <a:avLst/>
-          </a:prstGeom>
-          <a:solidFill>
-            <a:srgbClr val="00B4D8">
-              <a:alpha val="20000"/>
-            </a:srgbClr>
-          </a:solidFill>
-          <a:ln w="12700">
-            <a:solidFill>
-              <a:srgbClr val="FFFFFF">
-                <a:alpha val="0"/>
-              </a:srgbClr>
-            </a:solidFill>
-            <a:prstDash val="solid"/>
-          </a:ln>
-        </p:spPr>
-        <p:txBody>
-          <a:bodyPr/>
-          <a:lstStyle/>
-          <a:p>
-            <a:endParaRPr lang="es-ES"/>
-          </a:p>
-        </p:txBody>
-      </p:sp>
-      <p:sp>
-        <p:nvSpPr>
           <p:cNvPr id="5" name="Shape 3"/>
           <p:cNvSpPr/>
           <p:nvPr/>
@@ -1419,7 +1347,23 @@
                   <a:srgbClr val="7B97AA"/>
                 </a:solidFill>
               </a:rPr>
-              <a:t>  ·  TF-IDF + NMF</a:t>
+              <a:t>  ·  </a:t>
+            </a:r>
+            <a:r>
+              <a:rPr lang="en-US" sz="1200" dirty="0" err="1">
+                <a:solidFill>
+                  <a:srgbClr val="7B97AA"/>
+                </a:solidFill>
+              </a:rPr>
+              <a:t>DistilBERT</a:t>
+            </a:r>
+            <a:r>
+              <a:rPr lang="en-US" sz="1200" dirty="0">
+                <a:solidFill>
+                  <a:srgbClr val="7B97AA"/>
+                </a:solidFill>
+              </a:rPr>
+              <a:t> + TF-IDF/NMF</a:t>
             </a:r>
             <a:endParaRPr lang="en-US" sz="1200" dirty="0"/>
           </a:p>
@@ -3378,7 +3322,7 @@
                   <a:srgbClr val="0077B6"/>
                 </a:solidFill>
               </a:rPr>
-              <a:t> 40 de 68 </a:t>
+              <a:t> 35 de 63 </a:t>
             </a:r>
             <a:r>
               <a:rPr lang="en-US" sz="1100" i="1" dirty="0" err="1">
@@ -3394,7 +3338,7 @@
                   <a:srgbClr val="0077B6"/>
                 </a:solidFill>
               </a:rPr>
-              <a:t> con mas de 25 </a:t>
+              <a:t> con mas de 30 </a:t>
             </a:r>
             <a:r>
               <a:rPr lang="en-US" sz="1100" i="1" dirty="0" err="1">
@@ -5634,78 +5578,6 @@
       </p:grpSpPr>
       <p:sp>
         <p:nvSpPr>
-          <p:cNvPr id="2" name="Shape 0"/>
-          <p:cNvSpPr/>
-          <p:nvPr/>
-        </p:nvSpPr>
-        <p:spPr>
-          <a:xfrm>
-            <a:off x="7772400" y="-457200"/>
-            <a:ext cx="2286000" cy="2286000"/>
-          </a:xfrm>
-          <a:prstGeom prst="ellipse">
-            <a:avLst/>
-          </a:prstGeom>
-          <a:solidFill>
-            <a:srgbClr val="00B4D8">
-              <a:alpha val="20000"/>
-            </a:srgbClr>
-          </a:solidFill>
-          <a:ln w="12700">
-            <a:solidFill>
-              <a:srgbClr val="FFFFFF">
-                <a:alpha val="0"/>
-              </a:srgbClr>
-            </a:solidFill>
-            <a:prstDash val="solid"/>
-          </a:ln>
-        </p:spPr>
-        <p:txBody>
-          <a:bodyPr/>
-          <a:lstStyle/>
-          <a:p>
-            <a:endParaRPr lang="es-ES"/>
-          </a:p>
-        </p:txBody>
-      </p:sp>
-      <p:sp>
-        <p:nvSpPr>
-          <p:cNvPr id="3" name="Shape 1"/>
-          <p:cNvSpPr/>
-          <p:nvPr/>
-        </p:nvSpPr>
-        <p:spPr>
-          <a:xfrm>
-            <a:off x="-457200" y="3657600"/>
-            <a:ext cx="1828800" cy="1828800"/>
-          </a:xfrm>
-          <a:prstGeom prst="ellipse">
-            <a:avLst/>
-          </a:prstGeom>
-          <a:solidFill>
-            <a:srgbClr val="0077B6">
-              <a:alpha val="25000"/>
-            </a:srgbClr>
-          </a:solidFill>
-          <a:ln w="12700">
-            <a:solidFill>
-              <a:srgbClr val="FFFFFF">
-                <a:alpha val="0"/>
-              </a:srgbClr>
-            </a:solidFill>
-            <a:prstDash val="solid"/>
-          </a:ln>
-        </p:spPr>
-        <p:txBody>
-          <a:bodyPr/>
-          <a:lstStyle/>
-          <a:p>
-            <a:endParaRPr lang="es-ES" u="sng" dirty="0"/>
-          </a:p>
-        </p:txBody>
-      </p:sp>
-      <p:sp>
-        <p:nvSpPr>
           <p:cNvPr id="4" name="Shape 2"/>
           <p:cNvSpPr/>
           <p:nvPr/>
@@ -6144,8 +6016,8 @@
         </p:nvSpPr>
         <p:spPr>
           <a:xfrm>
-            <a:off x="274320" y="3017520"/>
-            <a:ext cx="8595360" cy="1005840"/>
+            <a:off x="274320" y="3108960"/>
+            <a:ext cx="8595360" cy="1258435"/>
           </a:xfrm>
           <a:prstGeom prst="rect">
             <a:avLst/>
@@ -6176,7 +6048,7 @@
         </p:nvSpPr>
         <p:spPr>
           <a:xfrm>
-            <a:off x="457200" y="3063240"/>
+            <a:off x="457200" y="3129145"/>
             <a:ext cx="2286000" cy="274320"/>
           </a:xfrm>
           <a:prstGeom prst="rect">
@@ -6198,7 +6070,7 @@
                   <a:srgbClr val="00B4D8"/>
                 </a:solidFill>
               </a:rPr>
-              <a:t>Conclusión</a:t>
+              <a:t>CONCLUSIÓN Y ACCIONDES DE MEJORA</a:t>
             </a:r>
             <a:endParaRPr lang="en-US" sz="1000" dirty="0"/>
           </a:p>
@@ -6212,8 +6084,8 @@
         </p:nvSpPr>
         <p:spPr>
           <a:xfrm>
-            <a:off x="457200" y="3337560"/>
-            <a:ext cx="8321040" cy="640080"/>
+            <a:off x="457200" y="3383279"/>
+            <a:ext cx="8321040" cy="747733"/>
           </a:xfrm>
           <a:prstGeom prst="rect">
             <a:avLst/>
@@ -6236,13 +6108,50 @@
               </a:rPr>
               <a:t>dice.fm destaca en la experiencia de compra — su app y proceso de reserva están por encima del sector — pero pierde la confianza del usuario en el postventa. </a:t>
             </a:r>
+          </a:p>
+          <a:p>
+            <a:pPr marL="0" indent="0">
+              <a:buNone/>
+            </a:pPr>
+            <a:r>
+              <a:rPr lang="en-US" sz="1100" i="1" dirty="0" err="1">
+                <a:solidFill>
+                  <a:srgbClr val="FFFFFF"/>
+                </a:solidFill>
+              </a:rPr>
+              <a:t>Mejorar</a:t>
+            </a:r>
+            <a:r>
+              <a:rPr lang="en-US" sz="1100" i="1" dirty="0">
+                <a:solidFill>
+                  <a:srgbClr val="FFFFFF"/>
+                </a:solidFill>
+              </a:rPr>
+              <a:t> los </a:t>
+            </a:r>
             <a:r>
               <a:rPr lang="en-US" sz="1100" b="1" i="1" dirty="0">
                 <a:solidFill>
                   <a:srgbClr val="FFFFFF"/>
                 </a:solidFill>
               </a:rPr>
-              <a:t>Mejorar los tiempos de respuesta del soporte </a:t>
+              <a:t>tiempos de respuesta del </a:t>
+            </a:r>
+            <a:r>
+              <a:rPr lang="en-US" sz="1100" b="1" i="1" dirty="0" err="1">
+                <a:solidFill>
+                  <a:srgbClr val="FFFFFF"/>
+                </a:solidFill>
+              </a:rPr>
+              <a:t>soporte</a:t>
+            </a:r>
+            <a:r>
+              <a:rPr lang="en-US" sz="1100" b="1" i="1" dirty="0">
+                <a:solidFill>
+                  <a:srgbClr val="FFFFFF"/>
+                </a:solidFill>
+              </a:rPr>
+              <a:t> </a:t>
             </a:r>
             <a:r>
               <a:rPr lang="en-US" sz="1100" i="1" dirty="0">
@@ -6250,7 +6159,7 @@
                   <a:srgbClr val="FFFFFF"/>
                 </a:solidFill>
               </a:rPr>
-              <a:t>y revisar la </a:t>
+              <a:t>y la</a:t>
             </a:r>
             <a:r>
               <a:rPr lang="en-US" sz="1100" b="1" i="1" dirty="0">
@@ -6258,6 +6167,70 @@
                   <a:srgbClr val="FFFFFF"/>
                 </a:solidFill>
               </a:rPr>
+              <a:t> gestion de </a:t>
+            </a:r>
+            <a:r>
+              <a:rPr lang="en-US" sz="1100" b="1" i="1" dirty="0" err="1">
+                <a:solidFill>
+                  <a:srgbClr val="FFFFFF"/>
+                </a:solidFill>
+              </a:rPr>
+              <a:t>cancelaciones</a:t>
+            </a:r>
+            <a:r>
+              <a:rPr lang="en-US" sz="1100" b="1" i="1" dirty="0">
+                <a:solidFill>
+                  <a:srgbClr val="FFFFFF"/>
+                </a:solidFill>
+              </a:rPr>
+              <a:t> </a:t>
+            </a:r>
+            <a:r>
+              <a:rPr lang="en-US" sz="1100" i="1" dirty="0">
+                <a:solidFill>
+                  <a:srgbClr val="FFFFFF"/>
+                </a:solidFill>
+              </a:rPr>
+              <a:t>de </a:t>
+            </a:r>
+            <a:r>
+              <a:rPr lang="en-US" sz="1100" i="1" dirty="0" err="1">
+                <a:solidFill>
+                  <a:srgbClr val="FFFFFF"/>
+                </a:solidFill>
+              </a:rPr>
+              <a:t>los</a:t>
+            </a:r>
+            <a:r>
+              <a:rPr lang="en-US" sz="1100" i="1" dirty="0">
+                <a:solidFill>
+                  <a:srgbClr val="FFFFFF"/>
+                </a:solidFill>
+              </a:rPr>
+              <a:t> </a:t>
+            </a:r>
+            <a:r>
+              <a:rPr lang="en-US" sz="1100" i="1" dirty="0" err="1">
+                <a:solidFill>
+                  <a:srgbClr val="FFFFFF"/>
+                </a:solidFill>
+              </a:rPr>
+              <a:t>eventos</a:t>
+            </a:r>
+            <a:r>
+              <a:rPr lang="en-US" sz="1100" i="1" dirty="0">
+                <a:solidFill>
+                  <a:srgbClr val="FFFFFF"/>
+                </a:solidFill>
+              </a:rPr>
+              <a:t>, revisar la </a:t>
+            </a:r>
+            <a:r>
+              <a:rPr lang="en-US" sz="1100" b="1" i="1" dirty="0">
+                <a:solidFill>
+                  <a:srgbClr val="FFFFFF"/>
+                </a:solidFill>
+              </a:rPr>
               <a:t>política de reembolsos </a:t>
             </a:r>
             <a:r>
@@ -6274,14 +6247,20 @@
       </p:sp>
       <p:sp>
         <p:nvSpPr>
-          <p:cNvPr id="17" name="Text 15"/>
-          <p:cNvSpPr/>
-          <p:nvPr/>
-        </p:nvSpPr>
-        <p:spPr>
-          <a:xfrm>
-            <a:off x="274320" y="4160520"/>
-            <a:ext cx="8595360" cy="320040"/>
+          <p:cNvPr id="18" name="Text 14">
+            <a:extLst>
+              <a:ext uri="{FF2B5EF4-FFF2-40B4-BE49-F238E27FC236}">
+                <a16:creationId xmlns:a16="http://schemas.microsoft.com/office/drawing/2014/main" id="{6F3BC430-336E-04E6-2745-A814990F1FAD}"/>
+              </a:ext>
+            </a:extLst>
+          </p:cNvPr>
+          <p:cNvSpPr/>
+          <p:nvPr/>
+        </p:nvSpPr>
+        <p:spPr>
+          <a:xfrm>
+            <a:off x="365760" y="4320540"/>
+            <a:ext cx="8321040" cy="747733"/>
           </a:xfrm>
           <a:prstGeom prst="rect">
             <a:avLst/>
@@ -6297,14 +6276,341 @@
               <a:buNone/>
             </a:pPr>
             <a:r>
-              <a:rPr lang="en-US" sz="950" i="1" dirty="0">
-                <a:solidFill>
-                  <a:srgbClr val="7B97AA"/>
-                </a:solidFill>
-              </a:rPr>
-              <a:t>Próximos pasos: Análisis de estrellas correlacionado con sentimiento  ·  Detección de idioma por reseña  ·  Seguimiento mensual de KPIs</a:t>
-            </a:r>
-            <a:endParaRPr lang="en-US" sz="950" dirty="0"/>
+              <a:rPr lang="en-US" sz="1100" i="1" dirty="0" err="1">
+                <a:solidFill>
+                  <a:schemeClr val="bg1"/>
+                </a:solidFill>
+              </a:rPr>
+              <a:t>Próximos</a:t>
+            </a:r>
+            <a:r>
+              <a:rPr lang="en-US" sz="1100" i="1" dirty="0">
+                <a:solidFill>
+                  <a:schemeClr val="bg1"/>
+                </a:solidFill>
+              </a:rPr>
+              <a:t> pasos: </a:t>
+            </a:r>
+            <a:r>
+              <a:rPr lang="en-US" sz="1100" i="1" dirty="0" err="1">
+                <a:solidFill>
+                  <a:schemeClr val="bg1"/>
+                </a:solidFill>
+              </a:rPr>
+              <a:t>Analizar</a:t>
+            </a:r>
+            <a:r>
+              <a:rPr lang="en-US" sz="1100" i="1" dirty="0">
+                <a:solidFill>
+                  <a:schemeClr val="bg1"/>
+                </a:solidFill>
+              </a:rPr>
+              <a:t> </a:t>
+            </a:r>
+            <a:r>
+              <a:rPr lang="en-US" sz="1100" i="1" dirty="0" err="1">
+                <a:solidFill>
+                  <a:schemeClr val="bg1"/>
+                </a:solidFill>
+              </a:rPr>
+              <a:t>más</a:t>
+            </a:r>
+            <a:r>
+              <a:rPr lang="en-US" sz="1100" i="1" dirty="0">
+                <a:solidFill>
+                  <a:schemeClr val="bg1"/>
+                </a:solidFill>
+              </a:rPr>
+              <a:t> a </a:t>
+            </a:r>
+            <a:r>
+              <a:rPr lang="en-US" sz="1100" i="1" dirty="0" err="1">
+                <a:solidFill>
+                  <a:schemeClr val="bg1"/>
+                </a:solidFill>
+              </a:rPr>
+              <a:t>fondo</a:t>
+            </a:r>
+            <a:r>
+              <a:rPr lang="en-US" sz="1100" i="1" dirty="0">
+                <a:solidFill>
+                  <a:schemeClr val="bg1"/>
+                </a:solidFill>
+              </a:rPr>
+              <a:t> de </a:t>
+            </a:r>
+            <a:r>
+              <a:rPr lang="en-US" sz="1100" i="1" dirty="0" err="1">
+                <a:solidFill>
+                  <a:schemeClr val="bg1"/>
+                </a:solidFill>
+              </a:rPr>
+              <a:t>dónde</a:t>
+            </a:r>
+            <a:r>
+              <a:rPr lang="en-US" sz="1100" i="1" dirty="0">
+                <a:solidFill>
+                  <a:schemeClr val="bg1"/>
+                </a:solidFill>
+              </a:rPr>
+              <a:t> </a:t>
+            </a:r>
+            <a:r>
+              <a:rPr lang="en-US" sz="1100" i="1" dirty="0" err="1">
+                <a:solidFill>
+                  <a:schemeClr val="bg1"/>
+                </a:solidFill>
+              </a:rPr>
+              <a:t>vienen</a:t>
+            </a:r>
+            <a:r>
+              <a:rPr lang="en-US" sz="1100" i="1" dirty="0">
+                <a:solidFill>
+                  <a:schemeClr val="bg1"/>
+                </a:solidFill>
+              </a:rPr>
+              <a:t> las </a:t>
+            </a:r>
+            <a:r>
+              <a:rPr lang="en-US" sz="1100" i="1" dirty="0" err="1">
+                <a:solidFill>
+                  <a:schemeClr val="bg1"/>
+                </a:solidFill>
+              </a:rPr>
+              <a:t>reseñas</a:t>
+            </a:r>
+            <a:r>
+              <a:rPr lang="en-US" sz="1100" i="1" dirty="0">
+                <a:solidFill>
+                  <a:schemeClr val="bg1"/>
+                </a:solidFill>
+              </a:rPr>
+              <a:t> </a:t>
+            </a:r>
+            <a:r>
+              <a:rPr lang="en-US" sz="1100" i="1" dirty="0" err="1">
+                <a:solidFill>
+                  <a:schemeClr val="bg1"/>
+                </a:solidFill>
+              </a:rPr>
+              <a:t>negativas</a:t>
+            </a:r>
+            <a:r>
+              <a:rPr lang="en-US" sz="1100" i="1" dirty="0">
+                <a:solidFill>
+                  <a:schemeClr val="bg1"/>
+                </a:solidFill>
+              </a:rPr>
+              <a:t> de </a:t>
+            </a:r>
+            <a:r>
+              <a:rPr lang="en-US" sz="1100" i="1" dirty="0" err="1">
+                <a:solidFill>
+                  <a:schemeClr val="bg1"/>
+                </a:solidFill>
+              </a:rPr>
+              <a:t>reembolsos</a:t>
+            </a:r>
+            <a:r>
+              <a:rPr lang="en-US" sz="1100" i="1" dirty="0">
+                <a:solidFill>
+                  <a:schemeClr val="bg1"/>
+                </a:solidFill>
+              </a:rPr>
+              <a:t> y </a:t>
+            </a:r>
+            <a:r>
+              <a:rPr lang="en-US" sz="1100" i="1" dirty="0" err="1">
+                <a:solidFill>
+                  <a:schemeClr val="bg1"/>
+                </a:solidFill>
+              </a:rPr>
+              <a:t>pagos</a:t>
+            </a:r>
+            <a:r>
+              <a:rPr lang="en-US" sz="1100" i="1" dirty="0">
+                <a:solidFill>
+                  <a:schemeClr val="bg1"/>
+                </a:solidFill>
+              </a:rPr>
+              <a:t> y </a:t>
+            </a:r>
+            <a:r>
+              <a:rPr lang="en-US" sz="1100" i="1" dirty="0" err="1">
+                <a:solidFill>
+                  <a:schemeClr val="bg1"/>
+                </a:solidFill>
+              </a:rPr>
+              <a:t>servicio</a:t>
+            </a:r>
+            <a:r>
+              <a:rPr lang="en-US" sz="1100" i="1" dirty="0">
+                <a:solidFill>
+                  <a:schemeClr val="bg1"/>
+                </a:solidFill>
+              </a:rPr>
+              <a:t> al </a:t>
+            </a:r>
+            <a:r>
+              <a:rPr lang="en-US" sz="1100" i="1" dirty="0" err="1">
+                <a:solidFill>
+                  <a:schemeClr val="bg1"/>
+                </a:solidFill>
+              </a:rPr>
+              <a:t>cliente</a:t>
+            </a:r>
+            <a:r>
+              <a:rPr lang="en-US" sz="1100" i="1" dirty="0">
+                <a:solidFill>
+                  <a:schemeClr val="bg1"/>
+                </a:solidFill>
+              </a:rPr>
+              <a:t>, para </a:t>
+            </a:r>
+            <a:r>
+              <a:rPr lang="en-US" sz="1100" i="1" dirty="0" err="1">
+                <a:solidFill>
+                  <a:schemeClr val="bg1"/>
+                </a:solidFill>
+              </a:rPr>
+              <a:t>proponer</a:t>
+            </a:r>
+            <a:r>
+              <a:rPr lang="en-US" sz="1100" i="1" dirty="0">
+                <a:solidFill>
+                  <a:schemeClr val="bg1"/>
+                </a:solidFill>
+              </a:rPr>
+              <a:t> </a:t>
+            </a:r>
+            <a:r>
+              <a:rPr lang="en-US" sz="1100" i="1" dirty="0" err="1">
+                <a:solidFill>
+                  <a:schemeClr val="bg1"/>
+                </a:solidFill>
+              </a:rPr>
+              <a:t>acciones</a:t>
+            </a:r>
+            <a:r>
+              <a:rPr lang="en-US" sz="1100" i="1" dirty="0">
+                <a:solidFill>
+                  <a:schemeClr val="bg1"/>
+                </a:solidFill>
+              </a:rPr>
+              <a:t> de </a:t>
+            </a:r>
+            <a:r>
+              <a:rPr lang="en-US" sz="1100" i="1" dirty="0" err="1">
+                <a:solidFill>
+                  <a:schemeClr val="bg1"/>
+                </a:solidFill>
+              </a:rPr>
+              <a:t>mejora</a:t>
+            </a:r>
+            <a:r>
+              <a:rPr lang="en-US" sz="1100" i="1" dirty="0">
+                <a:solidFill>
+                  <a:schemeClr val="bg1"/>
+                </a:solidFill>
+              </a:rPr>
+              <a:t> </a:t>
+            </a:r>
+            <a:r>
+              <a:rPr lang="en-US" sz="1100" i="1" dirty="0" err="1">
+                <a:solidFill>
+                  <a:schemeClr val="bg1"/>
+                </a:solidFill>
+              </a:rPr>
+              <a:t>más</a:t>
+            </a:r>
+            <a:r>
+              <a:rPr lang="en-US" sz="1100" i="1" dirty="0">
+                <a:solidFill>
+                  <a:schemeClr val="bg1"/>
+                </a:solidFill>
+              </a:rPr>
+              <a:t> </a:t>
+            </a:r>
+            <a:r>
+              <a:rPr lang="en-US" sz="1100" i="1" dirty="0" err="1">
+                <a:solidFill>
+                  <a:schemeClr val="bg1"/>
+                </a:solidFill>
+              </a:rPr>
+              <a:t>concretas</a:t>
+            </a:r>
+            <a:r>
+              <a:rPr lang="en-US" sz="1100" i="1" dirty="0">
+                <a:solidFill>
+                  <a:schemeClr val="bg1"/>
+                </a:solidFill>
+              </a:rPr>
+              <a:t> e </a:t>
+            </a:r>
+            <a:r>
+              <a:rPr lang="en-US" sz="1100" i="1" dirty="0" err="1">
+                <a:solidFill>
+                  <a:schemeClr val="bg1"/>
+                </a:solidFill>
+              </a:rPr>
+              <a:t>intentar</a:t>
+            </a:r>
+            <a:r>
+              <a:rPr lang="en-US" sz="1100" i="1" dirty="0">
+                <a:solidFill>
+                  <a:schemeClr val="bg1"/>
+                </a:solidFill>
+              </a:rPr>
+              <a:t> </a:t>
+            </a:r>
+            <a:r>
+              <a:rPr lang="en-US" sz="1100" i="1" dirty="0" err="1">
+                <a:solidFill>
+                  <a:schemeClr val="bg1"/>
+                </a:solidFill>
+              </a:rPr>
+              <a:t>encontrar</a:t>
+            </a:r>
+            <a:r>
+              <a:rPr lang="en-US" sz="1100" i="1" dirty="0">
+                <a:solidFill>
+                  <a:schemeClr val="bg1"/>
+                </a:solidFill>
+              </a:rPr>
+              <a:t> la </a:t>
+            </a:r>
+            <a:r>
+              <a:rPr lang="en-US" sz="1100" i="1" dirty="0" err="1">
+                <a:solidFill>
+                  <a:schemeClr val="bg1"/>
+                </a:solidFill>
+              </a:rPr>
+              <a:t>raíz</a:t>
+            </a:r>
+            <a:r>
+              <a:rPr lang="en-US" sz="1100" i="1" dirty="0">
+                <a:solidFill>
+                  <a:schemeClr val="bg1"/>
+                </a:solidFill>
+              </a:rPr>
+              <a:t> del </a:t>
+            </a:r>
+            <a:r>
+              <a:rPr lang="en-US" sz="1100" i="1" dirty="0" err="1">
+                <a:solidFill>
+                  <a:schemeClr val="bg1"/>
+                </a:solidFill>
+              </a:rPr>
+              <a:t>problema</a:t>
+            </a:r>
+            <a:r>
+              <a:rPr lang="en-US" sz="1100" i="1" dirty="0">
+                <a:solidFill>
+                  <a:schemeClr val="bg1"/>
+                </a:solidFill>
+              </a:rPr>
+              <a:t>. </a:t>
+            </a:r>
           </a:p>
         </p:txBody>
       </p:sp>

</xml_diff>